<commit_message>
Product Variant item- Fetch datatable data on condition
</commit_message>
<xml_diff>
--- a/.lessons/58 Backend Product And Related Features/27 Product Variant item- Fetch datatable data on condition/1.pptx
+++ b/.lessons/58 Backend Product And Related Features/27 Product Variant item- Fetch datatable data on condition/1.pptx
@@ -7,7 +7,12 @@
   <p:sldIdLst>
     <p:sldId id="413" r:id="rId2"/>
     <p:sldId id="414" r:id="rId3"/>
-    <p:sldId id="400" r:id="rId4"/>
+    <p:sldId id="415" r:id="rId4"/>
+    <p:sldId id="416" r:id="rId5"/>
+    <p:sldId id="417" r:id="rId6"/>
+    <p:sldId id="400" r:id="rId7"/>
+    <p:sldId id="418" r:id="rId8"/>
+    <p:sldId id="419" r:id="rId9"/>
   </p:sldIdLst>
   <p:sldSz cx="12192000" cy="6858000"/>
   <p:notesSz cx="6858000" cy="9144000"/>
@@ -261,7 +266,7 @@
           <a:p>
             <a:fld id="{3E102D2E-813C-461C-9963-687A650C48C0}" type="datetimeFigureOut">
               <a:rPr lang="en-US" smtClean="0"/>
-              <a:t>6/26/2025</a:t>
+              <a:t>10/9/2025</a:t>
             </a:fld>
             <a:endParaRPr lang="en-US"/>
           </a:p>
@@ -459,7 +464,7 @@
           <a:p>
             <a:fld id="{3E102D2E-813C-461C-9963-687A650C48C0}" type="datetimeFigureOut">
               <a:rPr lang="en-US" smtClean="0"/>
-              <a:t>6/26/2025</a:t>
+              <a:t>10/9/2025</a:t>
             </a:fld>
             <a:endParaRPr lang="en-US"/>
           </a:p>
@@ -667,7 +672,7 @@
           <a:p>
             <a:fld id="{3E102D2E-813C-461C-9963-687A650C48C0}" type="datetimeFigureOut">
               <a:rPr lang="en-US" smtClean="0"/>
-              <a:t>6/26/2025</a:t>
+              <a:t>10/9/2025</a:t>
             </a:fld>
             <a:endParaRPr lang="en-US"/>
           </a:p>
@@ -865,7 +870,7 @@
           <a:p>
             <a:fld id="{3E102D2E-813C-461C-9963-687A650C48C0}" type="datetimeFigureOut">
               <a:rPr lang="en-US" smtClean="0"/>
-              <a:t>6/26/2025</a:t>
+              <a:t>10/9/2025</a:t>
             </a:fld>
             <a:endParaRPr lang="en-US"/>
           </a:p>
@@ -1140,7 +1145,7 @@
           <a:p>
             <a:fld id="{3E102D2E-813C-461C-9963-687A650C48C0}" type="datetimeFigureOut">
               <a:rPr lang="en-US" smtClean="0"/>
-              <a:t>6/26/2025</a:t>
+              <a:t>10/9/2025</a:t>
             </a:fld>
             <a:endParaRPr lang="en-US"/>
           </a:p>
@@ -1405,7 +1410,7 @@
           <a:p>
             <a:fld id="{3E102D2E-813C-461C-9963-687A650C48C0}" type="datetimeFigureOut">
               <a:rPr lang="en-US" smtClean="0"/>
-              <a:t>6/26/2025</a:t>
+              <a:t>10/9/2025</a:t>
             </a:fld>
             <a:endParaRPr lang="en-US"/>
           </a:p>
@@ -1817,7 +1822,7 @@
           <a:p>
             <a:fld id="{3E102D2E-813C-461C-9963-687A650C48C0}" type="datetimeFigureOut">
               <a:rPr lang="en-US" smtClean="0"/>
-              <a:t>6/26/2025</a:t>
+              <a:t>10/9/2025</a:t>
             </a:fld>
             <a:endParaRPr lang="en-US"/>
           </a:p>
@@ -1958,7 +1963,7 @@
           <a:p>
             <a:fld id="{3E102D2E-813C-461C-9963-687A650C48C0}" type="datetimeFigureOut">
               <a:rPr lang="en-US" smtClean="0"/>
-              <a:t>6/26/2025</a:t>
+              <a:t>10/9/2025</a:t>
             </a:fld>
             <a:endParaRPr lang="en-US"/>
           </a:p>
@@ -2071,7 +2076,7 @@
           <a:p>
             <a:fld id="{3E102D2E-813C-461C-9963-687A650C48C0}" type="datetimeFigureOut">
               <a:rPr lang="en-US" smtClean="0"/>
-              <a:t>6/26/2025</a:t>
+              <a:t>10/9/2025</a:t>
             </a:fld>
             <a:endParaRPr lang="en-US"/>
           </a:p>
@@ -2382,7 +2387,7 @@
           <a:p>
             <a:fld id="{3E102D2E-813C-461C-9963-687A650C48C0}" type="datetimeFigureOut">
               <a:rPr lang="en-US" smtClean="0"/>
-              <a:t>6/26/2025</a:t>
+              <a:t>10/9/2025</a:t>
             </a:fld>
             <a:endParaRPr lang="en-US"/>
           </a:p>
@@ -2670,7 +2675,7 @@
           <a:p>
             <a:fld id="{3E102D2E-813C-461C-9963-687A650C48C0}" type="datetimeFigureOut">
               <a:rPr lang="en-US" smtClean="0"/>
-              <a:t>6/26/2025</a:t>
+              <a:t>10/9/2025</a:t>
             </a:fld>
             <a:endParaRPr lang="en-US"/>
           </a:p>
@@ -2911,7 +2916,7 @@
           <a:p>
             <a:fld id="{3E102D2E-813C-461C-9963-687A650C48C0}" type="datetimeFigureOut">
               <a:rPr lang="en-US" smtClean="0"/>
-              <a:t>6/26/2025</a:t>
+              <a:t>10/9/2025</a:t>
             </a:fld>
             <a:endParaRPr lang="en-US"/>
           </a:p>
@@ -3369,21 +3374,54 @@
               <a:buNone/>
             </a:pPr>
             <a:r>
-              <a:rPr kumimoji="0" lang="en-US" altLang="en-US" sz="1300" b="0" i="0" u="none" strike="noStrike" cap="none" normalizeH="0" baseline="0">
-                <a:ln>
-                  <a:noFill/>
-                </a:ln>
-                <a:solidFill>
-                  <a:schemeClr val="tx1"/>
-                </a:solidFill>
-                <a:effectLst/>
+              <a:rPr lang="az-Latn-AZ" altLang="en-US" sz="1300">
                 <a:latin typeface="Arial" panose="020B0604020202020204" pitchFamily="34" charset="0"/>
               </a:rPr>
-              <a:t>.</a:t>
-            </a:r>
-          </a:p>
-        </p:txBody>
-      </p:sp>
+              <a:t>Bu kodun mahiyyətini onu silərək göstərəcəm.</a:t>
+            </a:r>
+            <a:endParaRPr kumimoji="0" lang="en-US" altLang="en-US" sz="1300" b="0" i="0" u="none" strike="noStrike" cap="none" normalizeH="0" baseline="0">
+              <a:ln>
+                <a:noFill/>
+              </a:ln>
+              <a:solidFill>
+                <a:schemeClr val="tx1"/>
+              </a:solidFill>
+              <a:effectLst/>
+              <a:latin typeface="Arial" panose="020B0604020202020204" pitchFamily="34" charset="0"/>
+            </a:endParaRPr>
+          </a:p>
+        </p:txBody>
+      </p:sp>
+      <p:pic>
+        <p:nvPicPr>
+          <p:cNvPr id="4" name="Picture 3">
+            <a:extLst>
+              <a:ext uri="{FF2B5EF4-FFF2-40B4-BE49-F238E27FC236}">
+                <a16:creationId xmlns:a16="http://schemas.microsoft.com/office/drawing/2014/main" id="{FED544EB-DFD8-943A-99DA-9F8C34413BDD}"/>
+              </a:ext>
+            </a:extLst>
+          </p:cNvPr>
+          <p:cNvPicPr>
+            <a:picLocks noChangeAspect="1"/>
+          </p:cNvPicPr>
+          <p:nvPr/>
+        </p:nvPicPr>
+        <p:blipFill>
+          <a:blip r:embed="rId2"/>
+          <a:stretch>
+            <a:fillRect/>
+          </a:stretch>
+        </p:blipFill>
+        <p:spPr>
+          <a:xfrm>
+            <a:off x="5620432" y="0"/>
+            <a:ext cx="6571568" cy="6858000"/>
+          </a:xfrm>
+          <a:prstGeom prst="rect">
+            <a:avLst/>
+          </a:prstGeom>
+        </p:spPr>
+      </p:pic>
     </p:spTree>
     <p:extLst>
       <p:ext uri="{BB962C8B-B14F-4D97-AF65-F5344CB8AC3E}">
@@ -3455,21 +3493,54 @@
               <a:buNone/>
             </a:pPr>
             <a:r>
-              <a:rPr kumimoji="0" lang="en-US" altLang="en-US" sz="1300" b="0" i="0" u="none" strike="noStrike" cap="none" normalizeH="0" baseline="0">
-                <a:ln>
-                  <a:noFill/>
-                </a:ln>
-                <a:solidFill>
-                  <a:schemeClr val="tx1"/>
-                </a:solidFill>
-                <a:effectLst/>
+              <a:rPr lang="az-Latn-AZ" altLang="en-US" sz="1300">
                 <a:latin typeface="Arial" panose="020B0604020202020204" pitchFamily="34" charset="0"/>
               </a:rPr>
-              <a:t>.</a:t>
-            </a:r>
-          </a:p>
-        </p:txBody>
-      </p:sp>
+              <a:t>İlk olaraq onu belə dəyişin.</a:t>
+            </a:r>
+            <a:endParaRPr kumimoji="0" lang="en-US" altLang="en-US" sz="1300" b="0" i="0" u="none" strike="noStrike" cap="none" normalizeH="0" baseline="0">
+              <a:ln>
+                <a:noFill/>
+              </a:ln>
+              <a:solidFill>
+                <a:schemeClr val="tx1"/>
+              </a:solidFill>
+              <a:effectLst/>
+              <a:latin typeface="Arial" panose="020B0604020202020204" pitchFamily="34" charset="0"/>
+            </a:endParaRPr>
+          </a:p>
+        </p:txBody>
+      </p:sp>
+      <p:pic>
+        <p:nvPicPr>
+          <p:cNvPr id="4" name="Picture 3">
+            <a:extLst>
+              <a:ext uri="{FF2B5EF4-FFF2-40B4-BE49-F238E27FC236}">
+                <a16:creationId xmlns:a16="http://schemas.microsoft.com/office/drawing/2014/main" id="{EC20DFBB-997C-E78D-D2DA-DAC4749DB9EE}"/>
+              </a:ext>
+            </a:extLst>
+          </p:cNvPr>
+          <p:cNvPicPr>
+            <a:picLocks noChangeAspect="1"/>
+          </p:cNvPicPr>
+          <p:nvPr/>
+        </p:nvPicPr>
+        <p:blipFill>
+          <a:blip r:embed="rId2"/>
+          <a:stretch>
+            <a:fillRect/>
+          </a:stretch>
+        </p:blipFill>
+        <p:spPr>
+          <a:xfrm>
+            <a:off x="6980250" y="0"/>
+            <a:ext cx="5211750" cy="6858000"/>
+          </a:xfrm>
+          <a:prstGeom prst="rect">
+            <a:avLst/>
+          </a:prstGeom>
+        </p:spPr>
+      </p:pic>
     </p:spTree>
     <p:extLst>
       <p:ext uri="{BB962C8B-B14F-4D97-AF65-F5344CB8AC3E}">
@@ -3484,6 +3555,862 @@
 </file>
 
 <file path=ppt/slides/slide3.xml><?xml version="1.0" encoding="utf-8"?>
+<p:sld xmlns:a="http://schemas.openxmlformats.org/drawingml/2006/main" xmlns:r="http://schemas.openxmlformats.org/officeDocument/2006/relationships" xmlns:p="http://schemas.openxmlformats.org/presentationml/2006/main">
+  <p:cSld>
+    <p:spTree>
+      <p:nvGrpSpPr>
+        <p:cNvPr id="1" name="">
+          <a:extLst>
+            <a:ext uri="{FF2B5EF4-FFF2-40B4-BE49-F238E27FC236}">
+              <a16:creationId xmlns:a16="http://schemas.microsoft.com/office/drawing/2014/main" id="{F35B67F1-4CF7-0BE3-2B67-B0380F31CE3A}"/>
+            </a:ext>
+          </a:extLst>
+        </p:cNvPr>
+        <p:cNvGrpSpPr/>
+        <p:nvPr/>
+      </p:nvGrpSpPr>
+      <p:grpSpPr>
+        <a:xfrm>
+          <a:off x="0" y="0"/>
+          <a:ext cx="0" cy="0"/>
+          <a:chOff x="0" y="0"/>
+          <a:chExt cx="0" cy="0"/>
+        </a:xfrm>
+      </p:grpSpPr>
+      <p:sp>
+        <p:nvSpPr>
+          <p:cNvPr id="3" name="TextBox 2">
+            <a:extLst>
+              <a:ext uri="{FF2B5EF4-FFF2-40B4-BE49-F238E27FC236}">
+                <a16:creationId xmlns:a16="http://schemas.microsoft.com/office/drawing/2014/main" id="{475B0017-17D0-4557-29C4-90389F4B5284}"/>
+              </a:ext>
+            </a:extLst>
+          </p:cNvPr>
+          <p:cNvSpPr txBox="1"/>
+          <p:nvPr/>
+        </p:nvSpPr>
+        <p:spPr>
+          <a:xfrm>
+            <a:off x="217714" y="255046"/>
+            <a:ext cx="11756571" cy="355354"/>
+          </a:xfrm>
+          <a:prstGeom prst="rect">
+            <a:avLst/>
+          </a:prstGeom>
+          <a:noFill/>
+        </p:spPr>
+        <p:txBody>
+          <a:bodyPr wrap="square">
+            <a:spAutoFit/>
+          </a:bodyPr>
+          <a:lstStyle/>
+          <a:p>
+            <a:pPr>
+              <a:lnSpc>
+                <a:spcPct val="150000"/>
+              </a:lnSpc>
+              <a:buNone/>
+            </a:pPr>
+            <a:r>
+              <a:rPr lang="az-Latn-AZ" altLang="en-US" sz="1300">
+                <a:latin typeface="Arial" panose="020B0604020202020204" pitchFamily="34" charset="0"/>
+              </a:rPr>
+              <a:t>Size səhifəsinə daxil olun. Bu zaman COLOR ilə əlaqəli itemləri görəcəyik. </a:t>
+            </a:r>
+            <a:endParaRPr kumimoji="0" lang="en-US" altLang="en-US" sz="1300" b="0" i="0" u="none" strike="noStrike" cap="none" normalizeH="0" baseline="0">
+              <a:ln>
+                <a:noFill/>
+              </a:ln>
+              <a:solidFill>
+                <a:schemeClr val="tx1"/>
+              </a:solidFill>
+              <a:effectLst/>
+              <a:latin typeface="Arial" panose="020B0604020202020204" pitchFamily="34" charset="0"/>
+            </a:endParaRPr>
+          </a:p>
+        </p:txBody>
+      </p:sp>
+      <p:pic>
+        <p:nvPicPr>
+          <p:cNvPr id="4" name="Picture 3">
+            <a:extLst>
+              <a:ext uri="{FF2B5EF4-FFF2-40B4-BE49-F238E27FC236}">
+                <a16:creationId xmlns:a16="http://schemas.microsoft.com/office/drawing/2014/main" id="{3AACE273-D907-90D0-486A-1D170AFA4FDF}"/>
+              </a:ext>
+            </a:extLst>
+          </p:cNvPr>
+          <p:cNvPicPr>
+            <a:picLocks noChangeAspect="1"/>
+          </p:cNvPicPr>
+          <p:nvPr/>
+        </p:nvPicPr>
+        <p:blipFill>
+          <a:blip r:embed="rId2"/>
+          <a:stretch>
+            <a:fillRect/>
+          </a:stretch>
+        </p:blipFill>
+        <p:spPr>
+          <a:xfrm>
+            <a:off x="0" y="1221225"/>
+            <a:ext cx="12192000" cy="4415550"/>
+          </a:xfrm>
+          <a:prstGeom prst="rect">
+            <a:avLst/>
+          </a:prstGeom>
+          <a:ln>
+            <a:noFill/>
+          </a:ln>
+          <a:effectLst>
+            <a:outerShdw blurRad="292100" dist="139700" dir="2700000" algn="tl" rotWithShape="0">
+              <a:srgbClr val="333333">
+                <a:alpha val="65000"/>
+              </a:srgbClr>
+            </a:outerShdw>
+          </a:effectLst>
+        </p:spPr>
+      </p:pic>
+    </p:spTree>
+    <p:extLst>
+      <p:ext uri="{BB962C8B-B14F-4D97-AF65-F5344CB8AC3E}">
+        <p14:creationId xmlns:p14="http://schemas.microsoft.com/office/powerpoint/2010/main" val="1098650764"/>
+      </p:ext>
+    </p:extLst>
+  </p:cSld>
+  <p:clrMapOvr>
+    <a:masterClrMapping/>
+  </p:clrMapOvr>
+</p:sld>
+</file>
+
+<file path=ppt/slides/slide4.xml><?xml version="1.0" encoding="utf-8"?>
+<p:sld xmlns:a="http://schemas.openxmlformats.org/drawingml/2006/main" xmlns:r="http://schemas.openxmlformats.org/officeDocument/2006/relationships" xmlns:p="http://schemas.openxmlformats.org/presentationml/2006/main">
+  <p:cSld>
+    <p:spTree>
+      <p:nvGrpSpPr>
+        <p:cNvPr id="1" name="">
+          <a:extLst>
+            <a:ext uri="{FF2B5EF4-FFF2-40B4-BE49-F238E27FC236}">
+              <a16:creationId xmlns:a16="http://schemas.microsoft.com/office/drawing/2014/main" id="{0CA4CEF4-F7E4-D609-1FB2-92850B3F97E4}"/>
+            </a:ext>
+          </a:extLst>
+        </p:cNvPr>
+        <p:cNvGrpSpPr/>
+        <p:nvPr/>
+      </p:nvGrpSpPr>
+      <p:grpSpPr>
+        <a:xfrm>
+          <a:off x="0" y="0"/>
+          <a:ext cx="0" cy="0"/>
+          <a:chOff x="0" y="0"/>
+          <a:chExt cx="0" cy="0"/>
+        </a:xfrm>
+      </p:grpSpPr>
+      <p:sp>
+        <p:nvSpPr>
+          <p:cNvPr id="3" name="TextBox 2">
+            <a:extLst>
+              <a:ext uri="{FF2B5EF4-FFF2-40B4-BE49-F238E27FC236}">
+                <a16:creationId xmlns:a16="http://schemas.microsoft.com/office/drawing/2014/main" id="{A080471C-9625-772E-78A1-25E69BC84331}"/>
+              </a:ext>
+            </a:extLst>
+          </p:cNvPr>
+          <p:cNvSpPr txBox="1"/>
+          <p:nvPr/>
+        </p:nvSpPr>
+        <p:spPr>
+          <a:xfrm>
+            <a:off x="217714" y="255046"/>
+            <a:ext cx="11756571" cy="464871"/>
+          </a:xfrm>
+          <a:prstGeom prst="rect">
+            <a:avLst/>
+          </a:prstGeom>
+          <a:noFill/>
+        </p:spPr>
+        <p:txBody>
+          <a:bodyPr wrap="square">
+            <a:spAutoFit/>
+          </a:bodyPr>
+          <a:lstStyle/>
+          <a:p>
+            <a:pPr>
+              <a:lnSpc>
+                <a:spcPct val="150000"/>
+              </a:lnSpc>
+            </a:pPr>
+            <a:r>
+              <a:rPr lang="az-Latn-AZ" altLang="en-US" sz="1300">
+                <a:latin typeface="Arial" panose="020B0604020202020204" pitchFamily="34" charset="0"/>
+              </a:rPr>
+              <a:t>Bunun olmaması üçün sorğudan gələn </a:t>
+            </a:r>
+            <a:r>
+              <a:rPr lang="az-Latn-AZ" altLang="en-US" sz="1300" b="1">
+                <a:latin typeface="Arial" panose="020B0604020202020204" pitchFamily="34" charset="0"/>
+              </a:rPr>
+              <a:t>variandİd</a:t>
+            </a:r>
+            <a:r>
+              <a:rPr lang="az-Latn-AZ" altLang="en-US" sz="1300">
+                <a:latin typeface="Arial" panose="020B0604020202020204" pitchFamily="34" charset="0"/>
+              </a:rPr>
+              <a:t> -ni </a:t>
+            </a:r>
+            <a:r>
+              <a:rPr lang="az-Latn-AZ" altLang="en-US" sz="1300" b="1">
+                <a:latin typeface="Arial" panose="020B0604020202020204" pitchFamily="34" charset="0"/>
+              </a:rPr>
+              <a:t>item</a:t>
+            </a:r>
+            <a:r>
+              <a:rPr lang="az-Latn-AZ" altLang="en-US" sz="1300">
+                <a:latin typeface="Arial" panose="020B0604020202020204" pitchFamily="34" charset="0"/>
+              </a:rPr>
+              <a:t> cədvəlində olan `</a:t>
+            </a:r>
+            <a:r>
+              <a:rPr lang="en-US" b="1"/>
+              <a:t>product_variant_id</a:t>
+            </a:r>
+            <a:r>
+              <a:rPr lang="az-Latn-AZ" altLang="en-US" sz="1300">
+                <a:latin typeface="Arial" panose="020B0604020202020204" pitchFamily="34" charset="0"/>
+              </a:rPr>
+              <a:t>` ilə müqayisə edirik 1ci slaydda olan kodda.</a:t>
+            </a:r>
+            <a:endParaRPr kumimoji="0" lang="en-US" altLang="en-US" sz="1300" b="0" i="0" u="none" strike="noStrike" cap="none" normalizeH="0" baseline="0">
+              <a:ln>
+                <a:noFill/>
+              </a:ln>
+              <a:solidFill>
+                <a:schemeClr val="tx1"/>
+              </a:solidFill>
+              <a:effectLst/>
+              <a:latin typeface="Arial" panose="020B0604020202020204" pitchFamily="34" charset="0"/>
+            </a:endParaRPr>
+          </a:p>
+        </p:txBody>
+      </p:sp>
+      <p:pic>
+        <p:nvPicPr>
+          <p:cNvPr id="4" name="Picture 3">
+            <a:extLst>
+              <a:ext uri="{FF2B5EF4-FFF2-40B4-BE49-F238E27FC236}">
+                <a16:creationId xmlns:a16="http://schemas.microsoft.com/office/drawing/2014/main" id="{5DA0399D-7E2E-18BB-A366-F5FD2F320BF0}"/>
+              </a:ext>
+            </a:extLst>
+          </p:cNvPr>
+          <p:cNvPicPr>
+            <a:picLocks noChangeAspect="1"/>
+          </p:cNvPicPr>
+          <p:nvPr/>
+        </p:nvPicPr>
+        <p:blipFill>
+          <a:blip r:embed="rId2"/>
+          <a:stretch>
+            <a:fillRect/>
+          </a:stretch>
+        </p:blipFill>
+        <p:spPr>
+          <a:xfrm>
+            <a:off x="0" y="1233420"/>
+            <a:ext cx="12192000" cy="4391159"/>
+          </a:xfrm>
+          <a:prstGeom prst="rect">
+            <a:avLst/>
+          </a:prstGeom>
+          <a:ln>
+            <a:noFill/>
+          </a:ln>
+          <a:effectLst>
+            <a:outerShdw blurRad="292100" dist="139700" dir="2700000" algn="tl" rotWithShape="0">
+              <a:srgbClr val="333333">
+                <a:alpha val="65000"/>
+              </a:srgbClr>
+            </a:outerShdw>
+          </a:effectLst>
+        </p:spPr>
+      </p:pic>
+    </p:spTree>
+    <p:extLst>
+      <p:ext uri="{BB962C8B-B14F-4D97-AF65-F5344CB8AC3E}">
+        <p14:creationId xmlns:p14="http://schemas.microsoft.com/office/powerpoint/2010/main" val="3522720661"/>
+      </p:ext>
+    </p:extLst>
+  </p:cSld>
+  <p:clrMapOvr>
+    <a:masterClrMapping/>
+  </p:clrMapOvr>
+</p:sld>
+</file>
+
+<file path=ppt/slides/slide5.xml><?xml version="1.0" encoding="utf-8"?>
+<p:sld xmlns:a="http://schemas.openxmlformats.org/drawingml/2006/main" xmlns:r="http://schemas.openxmlformats.org/officeDocument/2006/relationships" xmlns:p="http://schemas.openxmlformats.org/presentationml/2006/main">
+  <p:cSld>
+    <p:spTree>
+      <p:nvGrpSpPr>
+        <p:cNvPr id="1" name="">
+          <a:extLst>
+            <a:ext uri="{FF2B5EF4-FFF2-40B4-BE49-F238E27FC236}">
+              <a16:creationId xmlns:a16="http://schemas.microsoft.com/office/drawing/2014/main" id="{67B663A0-035F-E7DC-0E4C-3C6EC8FC6990}"/>
+            </a:ext>
+          </a:extLst>
+        </p:cNvPr>
+        <p:cNvGrpSpPr/>
+        <p:nvPr/>
+      </p:nvGrpSpPr>
+      <p:grpSpPr>
+        <a:xfrm>
+          <a:off x="0" y="0"/>
+          <a:ext cx="0" cy="0"/>
+          <a:chOff x="0" y="0"/>
+          <a:chExt cx="0" cy="0"/>
+        </a:xfrm>
+      </p:grpSpPr>
+      <p:sp>
+        <p:nvSpPr>
+          <p:cNvPr id="3" name="TextBox 2">
+            <a:extLst>
+              <a:ext uri="{FF2B5EF4-FFF2-40B4-BE49-F238E27FC236}">
+                <a16:creationId xmlns:a16="http://schemas.microsoft.com/office/drawing/2014/main" id="{A375AC1B-243E-C8E3-55F1-608A98E62238}"/>
+              </a:ext>
+            </a:extLst>
+          </p:cNvPr>
+          <p:cNvSpPr txBox="1"/>
+          <p:nvPr/>
+        </p:nvSpPr>
+        <p:spPr>
+          <a:xfrm>
+            <a:off x="217714" y="255046"/>
+            <a:ext cx="11756571" cy="5456750"/>
+          </a:xfrm>
+          <a:prstGeom prst="rect">
+            <a:avLst/>
+          </a:prstGeom>
+          <a:noFill/>
+        </p:spPr>
+        <p:txBody>
+          <a:bodyPr wrap="square">
+            <a:spAutoFit/>
+          </a:bodyPr>
+          <a:lstStyle/>
+          <a:p>
+            <a:pPr>
+              <a:lnSpc>
+                <a:spcPct val="150000"/>
+              </a:lnSpc>
+              <a:buNone/>
+            </a:pPr>
+            <a:r>
+              <a:rPr lang="az-Latn-AZ" altLang="en-US" sz="1300">
+                <a:latin typeface="Arial" panose="020B0604020202020204" pitchFamily="34" charset="0"/>
+              </a:rPr>
+              <a:t>Həmin sorğuda olan identifikator</a:t>
+            </a:r>
+          </a:p>
+          <a:p>
+            <a:pPr>
+              <a:lnSpc>
+                <a:spcPct val="150000"/>
+              </a:lnSpc>
+              <a:buNone/>
+            </a:pPr>
+            <a:endParaRPr kumimoji="0" lang="az-Latn-AZ" altLang="en-US" sz="1300" b="0" i="0" u="none" strike="noStrike" cap="none" normalizeH="0" baseline="0">
+              <a:ln>
+                <a:noFill/>
+              </a:ln>
+              <a:solidFill>
+                <a:schemeClr val="tx1"/>
+              </a:solidFill>
+              <a:effectLst/>
+              <a:latin typeface="Arial" panose="020B0604020202020204" pitchFamily="34" charset="0"/>
+            </a:endParaRPr>
+          </a:p>
+          <a:p>
+            <a:pPr>
+              <a:lnSpc>
+                <a:spcPct val="150000"/>
+              </a:lnSpc>
+              <a:buNone/>
+            </a:pPr>
+            <a:endParaRPr lang="az-Latn-AZ" altLang="en-US" sz="1300">
+              <a:latin typeface="Arial" panose="020B0604020202020204" pitchFamily="34" charset="0"/>
+            </a:endParaRPr>
+          </a:p>
+          <a:p>
+            <a:pPr>
+              <a:lnSpc>
+                <a:spcPct val="150000"/>
+              </a:lnSpc>
+              <a:buNone/>
+            </a:pPr>
+            <a:endParaRPr kumimoji="0" lang="az-Latn-AZ" altLang="en-US" sz="1300" b="0" i="0" u="none" strike="noStrike" cap="none" normalizeH="0" baseline="0">
+              <a:ln>
+                <a:noFill/>
+              </a:ln>
+              <a:solidFill>
+                <a:schemeClr val="tx1"/>
+              </a:solidFill>
+              <a:effectLst/>
+              <a:latin typeface="Arial" panose="020B0604020202020204" pitchFamily="34" charset="0"/>
+            </a:endParaRPr>
+          </a:p>
+          <a:p>
+            <a:pPr>
+              <a:lnSpc>
+                <a:spcPct val="150000"/>
+              </a:lnSpc>
+              <a:buNone/>
+            </a:pPr>
+            <a:endParaRPr lang="az-Latn-AZ" altLang="en-US" sz="1300">
+              <a:latin typeface="Arial" panose="020B0604020202020204" pitchFamily="34" charset="0"/>
+            </a:endParaRPr>
+          </a:p>
+          <a:p>
+            <a:pPr>
+              <a:lnSpc>
+                <a:spcPct val="150000"/>
+              </a:lnSpc>
+              <a:buNone/>
+            </a:pPr>
+            <a:endParaRPr kumimoji="0" lang="az-Latn-AZ" altLang="en-US" sz="1300" b="0" i="0" u="none" strike="noStrike" cap="none" normalizeH="0" baseline="0">
+              <a:ln>
+                <a:noFill/>
+              </a:ln>
+              <a:solidFill>
+                <a:schemeClr val="tx1"/>
+              </a:solidFill>
+              <a:effectLst/>
+              <a:latin typeface="Arial" panose="020B0604020202020204" pitchFamily="34" charset="0"/>
+            </a:endParaRPr>
+          </a:p>
+          <a:p>
+            <a:pPr>
+              <a:lnSpc>
+                <a:spcPct val="150000"/>
+              </a:lnSpc>
+              <a:buNone/>
+            </a:pPr>
+            <a:endParaRPr lang="az-Latn-AZ" altLang="en-US" sz="1300">
+              <a:latin typeface="Arial" panose="020B0604020202020204" pitchFamily="34" charset="0"/>
+            </a:endParaRPr>
+          </a:p>
+          <a:p>
+            <a:pPr>
+              <a:lnSpc>
+                <a:spcPct val="150000"/>
+              </a:lnSpc>
+              <a:buNone/>
+            </a:pPr>
+            <a:endParaRPr kumimoji="0" lang="az-Latn-AZ" altLang="en-US" sz="1300" b="0" i="0" u="none" strike="noStrike" cap="none" normalizeH="0" baseline="0">
+              <a:ln>
+                <a:noFill/>
+              </a:ln>
+              <a:solidFill>
+                <a:schemeClr val="tx1"/>
+              </a:solidFill>
+              <a:effectLst/>
+              <a:latin typeface="Arial" panose="020B0604020202020204" pitchFamily="34" charset="0"/>
+            </a:endParaRPr>
+          </a:p>
+          <a:p>
+            <a:pPr>
+              <a:lnSpc>
+                <a:spcPct val="150000"/>
+              </a:lnSpc>
+              <a:buNone/>
+            </a:pPr>
+            <a:endParaRPr lang="az-Latn-AZ" altLang="en-US" sz="1300">
+              <a:latin typeface="Arial" panose="020B0604020202020204" pitchFamily="34" charset="0"/>
+            </a:endParaRPr>
+          </a:p>
+          <a:p>
+            <a:pPr>
+              <a:lnSpc>
+                <a:spcPct val="150000"/>
+              </a:lnSpc>
+              <a:buNone/>
+            </a:pPr>
+            <a:endParaRPr kumimoji="0" lang="az-Latn-AZ" altLang="en-US" sz="1300" b="0" i="0" u="none" strike="noStrike" cap="none" normalizeH="0" baseline="0">
+              <a:ln>
+                <a:noFill/>
+              </a:ln>
+              <a:solidFill>
+                <a:schemeClr val="tx1"/>
+              </a:solidFill>
+              <a:effectLst/>
+              <a:latin typeface="Arial" panose="020B0604020202020204" pitchFamily="34" charset="0"/>
+            </a:endParaRPr>
+          </a:p>
+          <a:p>
+            <a:pPr>
+              <a:lnSpc>
+                <a:spcPct val="150000"/>
+              </a:lnSpc>
+              <a:buNone/>
+            </a:pPr>
+            <a:endParaRPr lang="az-Latn-AZ" altLang="en-US" sz="1300">
+              <a:latin typeface="Arial" panose="020B0604020202020204" pitchFamily="34" charset="0"/>
+            </a:endParaRPr>
+          </a:p>
+          <a:p>
+            <a:pPr>
+              <a:lnSpc>
+                <a:spcPct val="150000"/>
+              </a:lnSpc>
+              <a:buNone/>
+            </a:pPr>
+            <a:endParaRPr kumimoji="0" lang="az-Latn-AZ" altLang="en-US" sz="1300" b="0" i="0" u="none" strike="noStrike" cap="none" normalizeH="0" baseline="0">
+              <a:ln>
+                <a:noFill/>
+              </a:ln>
+              <a:solidFill>
+                <a:schemeClr val="tx1"/>
+              </a:solidFill>
+              <a:effectLst/>
+              <a:latin typeface="Arial" panose="020B0604020202020204" pitchFamily="34" charset="0"/>
+            </a:endParaRPr>
+          </a:p>
+          <a:p>
+            <a:pPr>
+              <a:lnSpc>
+                <a:spcPct val="150000"/>
+              </a:lnSpc>
+              <a:buNone/>
+            </a:pPr>
+            <a:endParaRPr lang="az-Latn-AZ" altLang="en-US" sz="1300">
+              <a:latin typeface="Arial" panose="020B0604020202020204" pitchFamily="34" charset="0"/>
+            </a:endParaRPr>
+          </a:p>
+          <a:p>
+            <a:pPr>
+              <a:lnSpc>
+                <a:spcPct val="150000"/>
+              </a:lnSpc>
+              <a:buNone/>
+            </a:pPr>
+            <a:endParaRPr kumimoji="0" lang="az-Latn-AZ" altLang="en-US" sz="1300" b="0" i="0" u="none" strike="noStrike" cap="none" normalizeH="0" baseline="0">
+              <a:ln>
+                <a:noFill/>
+              </a:ln>
+              <a:solidFill>
+                <a:schemeClr val="tx1"/>
+              </a:solidFill>
+              <a:effectLst/>
+              <a:latin typeface="Arial" panose="020B0604020202020204" pitchFamily="34" charset="0"/>
+            </a:endParaRPr>
+          </a:p>
+          <a:p>
+            <a:pPr>
+              <a:lnSpc>
+                <a:spcPct val="150000"/>
+              </a:lnSpc>
+              <a:buNone/>
+            </a:pPr>
+            <a:endParaRPr lang="az-Latn-AZ" altLang="en-US" sz="1300">
+              <a:latin typeface="Arial" panose="020B0604020202020204" pitchFamily="34" charset="0"/>
+            </a:endParaRPr>
+          </a:p>
+          <a:p>
+            <a:pPr>
+              <a:lnSpc>
+                <a:spcPct val="150000"/>
+              </a:lnSpc>
+              <a:buNone/>
+            </a:pPr>
+            <a:endParaRPr kumimoji="0" lang="az-Latn-AZ" altLang="en-US" sz="1300" b="0" i="0" u="none" strike="noStrike" cap="none" normalizeH="0" baseline="0">
+              <a:ln>
+                <a:noFill/>
+              </a:ln>
+              <a:solidFill>
+                <a:schemeClr val="tx1"/>
+              </a:solidFill>
+              <a:effectLst/>
+              <a:latin typeface="Arial" panose="020B0604020202020204" pitchFamily="34" charset="0"/>
+            </a:endParaRPr>
+          </a:p>
+          <a:p>
+            <a:pPr>
+              <a:lnSpc>
+                <a:spcPct val="150000"/>
+              </a:lnSpc>
+              <a:buNone/>
+            </a:pPr>
+            <a:endParaRPr lang="az-Latn-AZ" altLang="en-US" sz="1300">
+              <a:latin typeface="Arial" panose="020B0604020202020204" pitchFamily="34" charset="0"/>
+            </a:endParaRPr>
+          </a:p>
+          <a:p>
+            <a:pPr>
+              <a:lnSpc>
+                <a:spcPct val="150000"/>
+              </a:lnSpc>
+              <a:buNone/>
+            </a:pPr>
+            <a:r>
+              <a:rPr kumimoji="0" lang="az-Latn-AZ" altLang="en-US" sz="1300" b="1" i="0" u="none" strike="noStrike" cap="none" normalizeH="0" baseline="0">
+                <a:ln>
+                  <a:noFill/>
+                </a:ln>
+                <a:solidFill>
+                  <a:schemeClr val="tx1"/>
+                </a:solidFill>
+                <a:effectLst/>
+                <a:latin typeface="Arial" panose="020B0604020202020204" pitchFamily="34" charset="0"/>
+              </a:rPr>
+              <a:t>Variant</a:t>
+            </a:r>
+            <a:r>
+              <a:rPr kumimoji="0" lang="az-Latn-AZ" altLang="en-US" sz="1300" b="0" i="0" u="none" strike="noStrike" cap="none" normalizeH="0" baseline="0">
+                <a:ln>
+                  <a:noFill/>
+                </a:ln>
+                <a:solidFill>
+                  <a:schemeClr val="tx1"/>
+                </a:solidFill>
+                <a:effectLst/>
+                <a:latin typeface="Arial" panose="020B0604020202020204" pitchFamily="34" charset="0"/>
+              </a:rPr>
+              <a:t> cədvəlində mövcuddur ancaq </a:t>
+            </a:r>
+            <a:r>
+              <a:rPr kumimoji="0" lang="az-Latn-AZ" altLang="en-US" sz="1300" b="1" i="0" u="none" strike="noStrike" cap="none" normalizeH="0" baseline="0">
+                <a:ln>
+                  <a:noFill/>
+                </a:ln>
+                <a:solidFill>
+                  <a:schemeClr val="tx1"/>
+                </a:solidFill>
+                <a:effectLst/>
+                <a:latin typeface="Arial" panose="020B0604020202020204" pitchFamily="34" charset="0"/>
+              </a:rPr>
+              <a:t>item</a:t>
+            </a:r>
+            <a:r>
+              <a:rPr kumimoji="0" lang="az-Latn-AZ" altLang="en-US" sz="1300" b="0" i="0" u="none" strike="noStrike" cap="none" normalizeH="0" baseline="0">
+                <a:ln>
+                  <a:noFill/>
+                </a:ln>
+                <a:solidFill>
+                  <a:schemeClr val="tx1"/>
+                </a:solidFill>
+                <a:effectLst/>
+                <a:latin typeface="Arial" panose="020B0604020202020204" pitchFamily="34" charset="0"/>
+              </a:rPr>
+              <a:t> cədvəlində identifikatoru </a:t>
+            </a:r>
+            <a:r>
+              <a:rPr kumimoji="0" lang="az-Latn-AZ" altLang="en-US" sz="1300" b="1" i="0" u="none" strike="noStrike" cap="none" normalizeH="0" baseline="0">
+                <a:ln>
+                  <a:noFill/>
+                </a:ln>
+                <a:solidFill>
+                  <a:schemeClr val="tx1"/>
+                </a:solidFill>
+                <a:effectLst/>
+                <a:latin typeface="Arial" panose="020B0604020202020204" pitchFamily="34" charset="0"/>
+              </a:rPr>
+              <a:t>2</a:t>
+            </a:r>
+            <a:r>
+              <a:rPr kumimoji="0" lang="az-Latn-AZ" altLang="en-US" sz="1300" b="0" i="0" u="none" strike="noStrike" cap="none" normalizeH="0" baseline="0">
+                <a:ln>
+                  <a:noFill/>
+                </a:ln>
+                <a:solidFill>
+                  <a:schemeClr val="tx1"/>
+                </a:solidFill>
+                <a:effectLst/>
+                <a:latin typeface="Arial" panose="020B0604020202020204" pitchFamily="34" charset="0"/>
+              </a:rPr>
+              <a:t> olan variant üçün heçnə yoxdur. Deməli heçnə görməməli idik ancaq biz </a:t>
+            </a:r>
+            <a:r>
+              <a:rPr kumimoji="0" lang="az-Latn-AZ" altLang="en-US" sz="1300" b="1" i="0" u="none" strike="noStrike" cap="none" normalizeH="0" baseline="0">
+                <a:ln>
+                  <a:noFill/>
+                </a:ln>
+                <a:solidFill>
+                  <a:schemeClr val="tx1"/>
+                </a:solidFill>
+                <a:effectLst/>
+                <a:latin typeface="Arial" panose="020B0604020202020204" pitchFamily="34" charset="0"/>
+              </a:rPr>
+              <a:t>color</a:t>
+            </a:r>
+            <a:r>
+              <a:rPr kumimoji="0" lang="az-Latn-AZ" altLang="en-US" sz="1300" b="0" i="0" u="none" strike="noStrike" cap="none" normalizeH="0" baseline="0">
+                <a:ln>
+                  <a:noFill/>
+                </a:ln>
+                <a:solidFill>
+                  <a:schemeClr val="tx1"/>
+                </a:solidFill>
+                <a:effectLst/>
+                <a:latin typeface="Arial" panose="020B0604020202020204" pitchFamily="34" charset="0"/>
+              </a:rPr>
+              <a:t> gördük.</a:t>
+            </a:r>
+            <a:endParaRPr kumimoji="0" lang="en-US" altLang="en-US" sz="1300" b="0" i="0" u="none" strike="noStrike" cap="none" normalizeH="0" baseline="0">
+              <a:ln>
+                <a:noFill/>
+              </a:ln>
+              <a:solidFill>
+                <a:schemeClr val="tx1"/>
+              </a:solidFill>
+              <a:effectLst/>
+              <a:latin typeface="Arial" panose="020B0604020202020204" pitchFamily="34" charset="0"/>
+            </a:endParaRPr>
+          </a:p>
+        </p:txBody>
+      </p:sp>
+      <p:pic>
+        <p:nvPicPr>
+          <p:cNvPr id="4" name="Picture 3">
+            <a:extLst>
+              <a:ext uri="{FF2B5EF4-FFF2-40B4-BE49-F238E27FC236}">
+                <a16:creationId xmlns:a16="http://schemas.microsoft.com/office/drawing/2014/main" id="{3DFF58EB-CBAE-AE46-17E1-EBAD43126E8C}"/>
+              </a:ext>
+            </a:extLst>
+          </p:cNvPr>
+          <p:cNvPicPr>
+            <a:picLocks noChangeAspect="1"/>
+          </p:cNvPicPr>
+          <p:nvPr/>
+        </p:nvPicPr>
+        <p:blipFill>
+          <a:blip r:embed="rId2"/>
+          <a:stretch>
+            <a:fillRect/>
+          </a:stretch>
+        </p:blipFill>
+        <p:spPr>
+          <a:xfrm>
+            <a:off x="0" y="822457"/>
+            <a:ext cx="12192000" cy="3956940"/>
+          </a:xfrm>
+          <a:prstGeom prst="rect">
+            <a:avLst/>
+          </a:prstGeom>
+          <a:ln w="38100" cap="sq">
+            <a:solidFill>
+              <a:srgbClr val="000000"/>
+            </a:solidFill>
+            <a:prstDash val="solid"/>
+            <a:miter lim="800000"/>
+          </a:ln>
+          <a:effectLst>
+            <a:outerShdw blurRad="50800" dist="38100" dir="2700000" algn="tl" rotWithShape="0">
+              <a:srgbClr val="000000">
+                <a:alpha val="43000"/>
+              </a:srgbClr>
+            </a:outerShdw>
+          </a:effectLst>
+        </p:spPr>
+      </p:pic>
+      <p:pic>
+        <p:nvPicPr>
+          <p:cNvPr id="6" name="Picture 5">
+            <a:extLst>
+              <a:ext uri="{FF2B5EF4-FFF2-40B4-BE49-F238E27FC236}">
+                <a16:creationId xmlns:a16="http://schemas.microsoft.com/office/drawing/2014/main" id="{0CA75A27-F43F-B788-3977-D0EB9C7CF891}"/>
+              </a:ext>
+            </a:extLst>
+          </p:cNvPr>
+          <p:cNvPicPr>
+            <a:picLocks noChangeAspect="1"/>
+          </p:cNvPicPr>
+          <p:nvPr/>
+        </p:nvPicPr>
+        <p:blipFill>
+          <a:blip r:embed="rId3"/>
+          <a:stretch>
+            <a:fillRect/>
+          </a:stretch>
+        </p:blipFill>
+        <p:spPr>
+          <a:xfrm>
+            <a:off x="87383" y="5872909"/>
+            <a:ext cx="5182323" cy="943107"/>
+          </a:xfrm>
+          <a:prstGeom prst="rect">
+            <a:avLst/>
+          </a:prstGeom>
+          <a:ln w="38100" cap="sq">
+            <a:solidFill>
+              <a:srgbClr val="000000"/>
+            </a:solidFill>
+            <a:prstDash val="solid"/>
+            <a:miter lim="800000"/>
+          </a:ln>
+          <a:effectLst>
+            <a:outerShdw blurRad="50800" dist="38100" dir="2700000" algn="tl" rotWithShape="0">
+              <a:srgbClr val="000000">
+                <a:alpha val="43000"/>
+              </a:srgbClr>
+            </a:outerShdw>
+          </a:effectLst>
+        </p:spPr>
+      </p:pic>
+      <p:pic>
+        <p:nvPicPr>
+          <p:cNvPr id="7" name="Picture 6">
+            <a:extLst>
+              <a:ext uri="{FF2B5EF4-FFF2-40B4-BE49-F238E27FC236}">
+                <a16:creationId xmlns:a16="http://schemas.microsoft.com/office/drawing/2014/main" id="{2E8DBCA4-5AA9-A60A-F1D0-6AD10A5FE19F}"/>
+              </a:ext>
+            </a:extLst>
+          </p:cNvPr>
+          <p:cNvPicPr>
+            <a:picLocks noChangeAspect="1"/>
+          </p:cNvPicPr>
+          <p:nvPr/>
+        </p:nvPicPr>
+        <p:blipFill>
+          <a:blip r:embed="rId4"/>
+          <a:stretch>
+            <a:fillRect/>
+          </a:stretch>
+        </p:blipFill>
+        <p:spPr>
+          <a:xfrm>
+            <a:off x="5788919" y="5872909"/>
+            <a:ext cx="6315698" cy="922321"/>
+          </a:xfrm>
+          <a:prstGeom prst="rect">
+            <a:avLst/>
+          </a:prstGeom>
+          <a:ln w="38100" cap="sq">
+            <a:solidFill>
+              <a:srgbClr val="000000"/>
+            </a:solidFill>
+            <a:prstDash val="solid"/>
+            <a:miter lim="800000"/>
+          </a:ln>
+          <a:effectLst>
+            <a:outerShdw blurRad="50800" dist="38100" dir="2700000" algn="tl" rotWithShape="0">
+              <a:srgbClr val="000000">
+                <a:alpha val="43000"/>
+              </a:srgbClr>
+            </a:outerShdw>
+          </a:effectLst>
+        </p:spPr>
+      </p:pic>
+    </p:spTree>
+    <p:extLst>
+      <p:ext uri="{BB962C8B-B14F-4D97-AF65-F5344CB8AC3E}">
+        <p14:creationId xmlns:p14="http://schemas.microsoft.com/office/powerpoint/2010/main" val="1931273065"/>
+      </p:ext>
+    </p:extLst>
+  </p:cSld>
+  <p:clrMapOvr>
+    <a:masterClrMapping/>
+  </p:clrMapOvr>
+</p:sld>
+</file>
+
+<file path=ppt/slides/slide6.xml><?xml version="1.0" encoding="utf-8"?>
 <p:sld xmlns:a="http://schemas.openxmlformats.org/drawingml/2006/main" xmlns:r="http://schemas.openxmlformats.org/officeDocument/2006/relationships" xmlns:p="http://schemas.openxmlformats.org/presentationml/2006/main">
   <p:cSld>
     <p:spTree>
@@ -3541,6 +4468,169 @@
               <a:buNone/>
             </a:pPr>
             <a:r>
+              <a:rPr lang="az-Latn-AZ" altLang="en-US" sz="1300">
+                <a:latin typeface="Arial" panose="020B0604020202020204" pitchFamily="34" charset="0"/>
+              </a:rPr>
+              <a:t>Kodu düzəldirik və hər şey işləyir</a:t>
+            </a:r>
+            <a:endParaRPr kumimoji="0" lang="en-US" altLang="en-US" sz="1300" b="0" i="0" u="none" strike="noStrike" cap="none" normalizeH="0" baseline="0">
+              <a:ln>
+                <a:noFill/>
+              </a:ln>
+              <a:solidFill>
+                <a:schemeClr val="tx1"/>
+              </a:solidFill>
+              <a:effectLst/>
+              <a:latin typeface="Arial" panose="020B0604020202020204" pitchFamily="34" charset="0"/>
+            </a:endParaRPr>
+          </a:p>
+        </p:txBody>
+      </p:sp>
+      <p:pic>
+        <p:nvPicPr>
+          <p:cNvPr id="6" name="Picture 5">
+            <a:extLst>
+              <a:ext uri="{FF2B5EF4-FFF2-40B4-BE49-F238E27FC236}">
+                <a16:creationId xmlns:a16="http://schemas.microsoft.com/office/drawing/2014/main" id="{1DD127C6-90DA-124C-E07E-2EEF131FF3B6}"/>
+              </a:ext>
+            </a:extLst>
+          </p:cNvPr>
+          <p:cNvPicPr>
+            <a:picLocks noChangeAspect="1"/>
+          </p:cNvPicPr>
+          <p:nvPr/>
+        </p:nvPicPr>
+        <p:blipFill>
+          <a:blip r:embed="rId2"/>
+          <a:stretch>
+            <a:fillRect/>
+          </a:stretch>
+        </p:blipFill>
+        <p:spPr>
+          <a:xfrm>
+            <a:off x="2942784" y="1066311"/>
+            <a:ext cx="6306430" cy="790685"/>
+          </a:xfrm>
+          <a:prstGeom prst="rect">
+            <a:avLst/>
+          </a:prstGeom>
+        </p:spPr>
+      </p:pic>
+      <p:pic>
+        <p:nvPicPr>
+          <p:cNvPr id="8" name="Picture 7">
+            <a:extLst>
+              <a:ext uri="{FF2B5EF4-FFF2-40B4-BE49-F238E27FC236}">
+                <a16:creationId xmlns:a16="http://schemas.microsoft.com/office/drawing/2014/main" id="{1D43D4F6-5721-20CF-1F53-A54F58A36380}"/>
+              </a:ext>
+            </a:extLst>
+          </p:cNvPr>
+          <p:cNvPicPr>
+            <a:picLocks noChangeAspect="1"/>
+          </p:cNvPicPr>
+          <p:nvPr/>
+        </p:nvPicPr>
+        <p:blipFill>
+          <a:blip r:embed="rId3"/>
+          <a:stretch>
+            <a:fillRect/>
+          </a:stretch>
+        </p:blipFill>
+        <p:spPr>
+          <a:xfrm>
+            <a:off x="129309" y="2829123"/>
+            <a:ext cx="12192000" cy="3416481"/>
+          </a:xfrm>
+          <a:prstGeom prst="rect">
+            <a:avLst/>
+          </a:prstGeom>
+          <a:ln w="38100" cap="sq">
+            <a:solidFill>
+              <a:srgbClr val="000000"/>
+            </a:solidFill>
+            <a:prstDash val="solid"/>
+            <a:miter lim="800000"/>
+          </a:ln>
+          <a:effectLst>
+            <a:outerShdw blurRad="50800" dist="38100" dir="2700000" algn="tl" rotWithShape="0">
+              <a:srgbClr val="000000">
+                <a:alpha val="43000"/>
+              </a:srgbClr>
+            </a:outerShdw>
+          </a:effectLst>
+        </p:spPr>
+      </p:pic>
+    </p:spTree>
+    <p:extLst>
+      <p:ext uri="{BB962C8B-B14F-4D97-AF65-F5344CB8AC3E}">
+        <p14:creationId xmlns:p14="http://schemas.microsoft.com/office/powerpoint/2010/main" val="3095838342"/>
+      </p:ext>
+    </p:extLst>
+  </p:cSld>
+  <p:clrMapOvr>
+    <a:masterClrMapping/>
+  </p:clrMapOvr>
+</p:sld>
+</file>
+
+<file path=ppt/slides/slide7.xml><?xml version="1.0" encoding="utf-8"?>
+<p:sld xmlns:a="http://schemas.openxmlformats.org/drawingml/2006/main" xmlns:r="http://schemas.openxmlformats.org/officeDocument/2006/relationships" xmlns:p="http://schemas.openxmlformats.org/presentationml/2006/main">
+  <p:cSld>
+    <p:spTree>
+      <p:nvGrpSpPr>
+        <p:cNvPr id="1" name="">
+          <a:extLst>
+            <a:ext uri="{FF2B5EF4-FFF2-40B4-BE49-F238E27FC236}">
+              <a16:creationId xmlns:a16="http://schemas.microsoft.com/office/drawing/2014/main" id="{7EC0E24B-899E-4277-BBDF-D500957D4767}"/>
+            </a:ext>
+          </a:extLst>
+        </p:cNvPr>
+        <p:cNvGrpSpPr/>
+        <p:nvPr/>
+      </p:nvGrpSpPr>
+      <p:grpSpPr>
+        <a:xfrm>
+          <a:off x="0" y="0"/>
+          <a:ext cx="0" cy="0"/>
+          <a:chOff x="0" y="0"/>
+          <a:chExt cx="0" cy="0"/>
+        </a:xfrm>
+      </p:grpSpPr>
+      <p:sp>
+        <p:nvSpPr>
+          <p:cNvPr id="3" name="TextBox 2">
+            <a:extLst>
+              <a:ext uri="{FF2B5EF4-FFF2-40B4-BE49-F238E27FC236}">
+                <a16:creationId xmlns:a16="http://schemas.microsoft.com/office/drawing/2014/main" id="{1BFEC2F5-913D-50E4-82C6-900FBC31EC93}"/>
+              </a:ext>
+            </a:extLst>
+          </p:cNvPr>
+          <p:cNvSpPr txBox="1"/>
+          <p:nvPr/>
+        </p:nvSpPr>
+        <p:spPr>
+          <a:xfrm>
+            <a:off x="217714" y="255046"/>
+            <a:ext cx="11756571" cy="355354"/>
+          </a:xfrm>
+          <a:prstGeom prst="rect">
+            <a:avLst/>
+          </a:prstGeom>
+          <a:noFill/>
+        </p:spPr>
+        <p:txBody>
+          <a:bodyPr wrap="square">
+            <a:spAutoFit/>
+          </a:bodyPr>
+          <a:lstStyle/>
+          <a:p>
+            <a:pPr>
+              <a:lnSpc>
+                <a:spcPct val="150000"/>
+              </a:lnSpc>
+              <a:buNone/>
+            </a:pPr>
+            <a:r>
               <a:rPr kumimoji="0" lang="en-US" altLang="en-US" sz="1300" b="0" i="0" u="none" strike="noStrike" cap="none" normalizeH="0" baseline="0">
                 <a:ln>
                   <a:noFill/>
@@ -3559,7 +4649,93 @@
     </p:spTree>
     <p:extLst>
       <p:ext uri="{BB962C8B-B14F-4D97-AF65-F5344CB8AC3E}">
-        <p14:creationId xmlns:p14="http://schemas.microsoft.com/office/powerpoint/2010/main" val="3095838342"/>
+        <p14:creationId xmlns:p14="http://schemas.microsoft.com/office/powerpoint/2010/main" val="4017313664"/>
+      </p:ext>
+    </p:extLst>
+  </p:cSld>
+  <p:clrMapOvr>
+    <a:masterClrMapping/>
+  </p:clrMapOvr>
+</p:sld>
+</file>
+
+<file path=ppt/slides/slide8.xml><?xml version="1.0" encoding="utf-8"?>
+<p:sld xmlns:a="http://schemas.openxmlformats.org/drawingml/2006/main" xmlns:r="http://schemas.openxmlformats.org/officeDocument/2006/relationships" xmlns:p="http://schemas.openxmlformats.org/presentationml/2006/main">
+  <p:cSld>
+    <p:spTree>
+      <p:nvGrpSpPr>
+        <p:cNvPr id="1" name="">
+          <a:extLst>
+            <a:ext uri="{FF2B5EF4-FFF2-40B4-BE49-F238E27FC236}">
+              <a16:creationId xmlns:a16="http://schemas.microsoft.com/office/drawing/2014/main" id="{168B11B1-D3E8-9D58-2E43-3D2FE06373B9}"/>
+            </a:ext>
+          </a:extLst>
+        </p:cNvPr>
+        <p:cNvGrpSpPr/>
+        <p:nvPr/>
+      </p:nvGrpSpPr>
+      <p:grpSpPr>
+        <a:xfrm>
+          <a:off x="0" y="0"/>
+          <a:ext cx="0" cy="0"/>
+          <a:chOff x="0" y="0"/>
+          <a:chExt cx="0" cy="0"/>
+        </a:xfrm>
+      </p:grpSpPr>
+      <p:sp>
+        <p:nvSpPr>
+          <p:cNvPr id="3" name="TextBox 2">
+            <a:extLst>
+              <a:ext uri="{FF2B5EF4-FFF2-40B4-BE49-F238E27FC236}">
+                <a16:creationId xmlns:a16="http://schemas.microsoft.com/office/drawing/2014/main" id="{ABF83A03-04DB-D7D6-915C-D71AF5F74ABB}"/>
+              </a:ext>
+            </a:extLst>
+          </p:cNvPr>
+          <p:cNvSpPr txBox="1"/>
+          <p:nvPr/>
+        </p:nvSpPr>
+        <p:spPr>
+          <a:xfrm>
+            <a:off x="217714" y="255046"/>
+            <a:ext cx="11756571" cy="355354"/>
+          </a:xfrm>
+          <a:prstGeom prst="rect">
+            <a:avLst/>
+          </a:prstGeom>
+          <a:noFill/>
+        </p:spPr>
+        <p:txBody>
+          <a:bodyPr wrap="square">
+            <a:spAutoFit/>
+          </a:bodyPr>
+          <a:lstStyle/>
+          <a:p>
+            <a:pPr>
+              <a:lnSpc>
+                <a:spcPct val="150000"/>
+              </a:lnSpc>
+              <a:buNone/>
+            </a:pPr>
+            <a:r>
+              <a:rPr kumimoji="0" lang="en-US" altLang="en-US" sz="1300" b="0" i="0" u="none" strike="noStrike" cap="none" normalizeH="0" baseline="0">
+                <a:ln>
+                  <a:noFill/>
+                </a:ln>
+                <a:solidFill>
+                  <a:schemeClr val="tx1"/>
+                </a:solidFill>
+                <a:effectLst/>
+                <a:latin typeface="Arial" panose="020B0604020202020204" pitchFamily="34" charset="0"/>
+              </a:rPr>
+              <a:t>.</a:t>
+            </a:r>
+          </a:p>
+        </p:txBody>
+      </p:sp>
+    </p:spTree>
+    <p:extLst>
+      <p:ext uri="{BB962C8B-B14F-4D97-AF65-F5344CB8AC3E}">
+        <p14:creationId xmlns:p14="http://schemas.microsoft.com/office/powerpoint/2010/main" val="860978927"/>
       </p:ext>
     </p:extLst>
   </p:cSld>

</xml_diff>